<commit_message>
Hilo entre PMO360 y FARO: anillo de 360° con cuatro cuartos de vuelta
Actualiza lámina (PPTX, PDF y PNG), guion para exponer, documento corto, guion de video
y ESPECIFICACION.md.

Co-Authored-By: Claude Sonnet 5.5 <noreply@anthropic.com>
Claude-Session: https://claude.ai/code/session_01WMKrhm5xPWgYnrpAyVAk9z
</commit_message>
<xml_diff>
--- a/docs/presentacion-faro/02-lamina-una-pagina.pptx
+++ b/docs/presentacion-faro/02-lamina-una-pagina.pptx
@@ -503,6 +503,7 @@
             <a:r>
               <a:rPr lang="en-US" dirty="0"/>
               <a:t>GUION BREVE (8 a 10 min en total; ver 01-guion-para-exponer.docx)
+HILO PMO360 ↔ FARO: PMO360 es la plataforma; el 360 es la vuelta completa (visión integral, sin puntos ciegos). FARO es cómo se explica y se adopta: cuatro pasos, uno por cada cuarto de vuelta (4 × 90° = 360°). PMO360 es la luz; FARO es cómo la mantenemos encendida.
 Apertura colegas: «Imaginen un barco, de noche, sin faro. No necesita una tormenta para chocar: le basta con no ver.» Apertura junta: abrir directo con tres preguntas: ¿cómo vamos?, ¿quién decide eso?, ¿de dónde salió ese número?
 F · Fuente única (2 min): la historia de Abraham Wald y los aviones. El semáforo usa cuatro dimensiones y manda la peor; si falta información dice «Sin datos». Pregunta a la sala: ¿cuántas versiones de un mismo proyecto circulan hoy?
 A · Alerta a tiempo (2 min): escena típica (no un caso real) del cambio que espera firma. Tablero «Requiere decisión», correo a quien decide, informe cada lunes 7:30 a. m. Pregunta: ¿cuántas decisiones esperan hoy a que alguien las vea?
@@ -1171,7 +1172,7 @@
         <p:spPr>
           <a:xfrm>
             <a:off x="1554480" y="2560320"/>
-            <a:ext cx="8229600" cy="365760"/>
+            <a:ext cx="7955280" cy="365760"/>
           </a:xfrm>
           <a:prstGeom prst="rect">
             <a:avLst/>
@@ -1187,12 +1188,23 @@
               <a:buNone/>
             </a:pPr>
             <a:r>
+              <a:rPr lang="en-US" sz="1600" b="1" dirty="0">
+                <a:solidFill>
+                  <a:schemeClr val="tx2"/>
+                </a:solidFill>
+              </a:rPr>
+              <a:t>PMO360 es la luz que gira los 360°: </a:t>
+            </a:r>
+            <a:pPr indent="0" marL="0">
+              <a:buNone/>
+            </a:pPr>
+            <a:r>
               <a:rPr lang="en-US" sz="1600" dirty="0">
                 <a:solidFill>
                   <a:schemeClr val="accent5"/>
                 </a:solidFill>
               </a:rPr>
-              <a:t>Cuatro pasos para decidir con claridad, a tiempo y con respaldo</a:t>
+              <a:t>cada paso ilumina un cuarto de vuelta</a:t>
             </a:r>
             <a:endParaRPr lang="en-US" sz="1600" dirty="0"/>
           </a:p>
@@ -1200,7 +1212,317 @@
       </p:sp>
       <p:sp>
         <p:nvSpPr>
-          <p:cNvPr id="13" name="Tarjeta F"/>
+          <p:cNvPr id="13" name="Cuarto F"/>
+          <p:cNvSpPr/>
+          <p:nvPr/>
+        </p:nvSpPr>
+        <p:spPr>
+          <a:xfrm>
+            <a:off x="9875520" y="1005840"/>
+            <a:ext cx="1828800" cy="1828800"/>
+          </a:xfrm>
+          <a:prstGeom prst="blockArc">
+            <a:avLst>
+              <a:gd name="adj1" fmla="val 16200000"/>
+              <a:gd name="adj2" fmla="val 21600000"/>
+              <a:gd name="adj3" fmla="val 21000"/>
+            </a:avLst>
+          </a:prstGeom>
+          <a:solidFill>
+            <a:schemeClr val="accent1"/>
+          </a:solidFill>
+          <a:ln w="25400">
+            <a:solidFill>
+              <a:schemeClr val="bg1"/>
+            </a:solidFill>
+            <a:prstDash val="solid"/>
+          </a:ln>
+        </p:spPr>
+      </p:sp>
+      <p:sp>
+        <p:nvSpPr>
+          <p:cNvPr id="14" name="Letra anillo F"/>
+          <p:cNvSpPr txBox="1"/>
+          <p:nvPr/>
+        </p:nvSpPr>
+        <p:spPr>
+          <a:xfrm>
+            <a:off x="11099549" y="1208275"/>
+            <a:ext cx="402336" cy="402336"/>
+          </a:xfrm>
+          <a:prstGeom prst="rect">
+            <a:avLst/>
+          </a:prstGeom>
+          <a:noFill/>
+          <a:ln/>
+        </p:spPr>
+        <p:txBody>
+          <a:bodyPr wrap="square" lIns="0" tIns="0" rIns="0" bIns="0" rtlCol="0" anchor="ctr"/>
+          <a:lstStyle/>
+          <a:p>
+            <a:pPr algn="ctr" indent="0" marL="0">
+              <a:buNone/>
+            </a:pPr>
+            <a:r>
+              <a:rPr lang="en-US" sz="2000" b="1" dirty="0">
+                <a:solidFill>
+                  <a:schemeClr val="bg1"/>
+                </a:solidFill>
+              </a:rPr>
+              <a:t>F</a:t>
+            </a:r>
+            <a:endParaRPr lang="en-US" sz="2000" dirty="0"/>
+          </a:p>
+        </p:txBody>
+      </p:sp>
+      <p:sp>
+        <p:nvSpPr>
+          <p:cNvPr id="15" name="Cuarto A"/>
+          <p:cNvSpPr/>
+          <p:nvPr/>
+        </p:nvSpPr>
+        <p:spPr>
+          <a:xfrm>
+            <a:off x="9875520" y="1005840"/>
+            <a:ext cx="1828800" cy="1828800"/>
+          </a:xfrm>
+          <a:prstGeom prst="blockArc">
+            <a:avLst>
+              <a:gd name="adj1" fmla="val 0"/>
+              <a:gd name="adj2" fmla="val 5400000"/>
+              <a:gd name="adj3" fmla="val 21000"/>
+            </a:avLst>
+          </a:prstGeom>
+          <a:solidFill>
+            <a:schemeClr val="accent6"/>
+          </a:solidFill>
+          <a:ln w="25400">
+            <a:solidFill>
+              <a:schemeClr val="bg1"/>
+            </a:solidFill>
+            <a:prstDash val="solid"/>
+          </a:ln>
+        </p:spPr>
+      </p:sp>
+      <p:sp>
+        <p:nvSpPr>
+          <p:cNvPr id="16" name="Letra anillo A"/>
+          <p:cNvSpPr txBox="1"/>
+          <p:nvPr/>
+        </p:nvSpPr>
+        <p:spPr>
+          <a:xfrm>
+            <a:off x="11099549" y="2229869"/>
+            <a:ext cx="402336" cy="402336"/>
+          </a:xfrm>
+          <a:prstGeom prst="rect">
+            <a:avLst/>
+          </a:prstGeom>
+          <a:noFill/>
+          <a:ln/>
+        </p:spPr>
+        <p:txBody>
+          <a:bodyPr wrap="square" lIns="0" tIns="0" rIns="0" bIns="0" rtlCol="0" anchor="ctr"/>
+          <a:lstStyle/>
+          <a:p>
+            <a:pPr algn="ctr" indent="0" marL="0">
+              <a:buNone/>
+            </a:pPr>
+            <a:r>
+              <a:rPr lang="en-US" sz="2000" b="1" dirty="0">
+                <a:solidFill>
+                  <a:schemeClr val="bg1"/>
+                </a:solidFill>
+              </a:rPr>
+              <a:t>A</a:t>
+            </a:r>
+            <a:endParaRPr lang="en-US" sz="2000" dirty="0"/>
+          </a:p>
+        </p:txBody>
+      </p:sp>
+      <p:sp>
+        <p:nvSpPr>
+          <p:cNvPr id="17" name="Cuarto R"/>
+          <p:cNvSpPr/>
+          <p:nvPr/>
+        </p:nvSpPr>
+        <p:spPr>
+          <a:xfrm>
+            <a:off x="9875520" y="1005840"/>
+            <a:ext cx="1828800" cy="1828800"/>
+          </a:xfrm>
+          <a:prstGeom prst="blockArc">
+            <a:avLst>
+              <a:gd name="adj1" fmla="val 5400000"/>
+              <a:gd name="adj2" fmla="val 10800000"/>
+              <a:gd name="adj3" fmla="val 21000"/>
+            </a:avLst>
+          </a:prstGeom>
+          <a:solidFill>
+            <a:schemeClr val="accent1"/>
+          </a:solidFill>
+          <a:ln w="25400">
+            <a:solidFill>
+              <a:schemeClr val="bg1"/>
+            </a:solidFill>
+            <a:prstDash val="solid"/>
+          </a:ln>
+        </p:spPr>
+      </p:sp>
+      <p:sp>
+        <p:nvSpPr>
+          <p:cNvPr id="18" name="Letra anillo R"/>
+          <p:cNvSpPr txBox="1"/>
+          <p:nvPr/>
+        </p:nvSpPr>
+        <p:spPr>
+          <a:xfrm>
+            <a:off x="10077955" y="2229869"/>
+            <a:ext cx="402336" cy="402336"/>
+          </a:xfrm>
+          <a:prstGeom prst="rect">
+            <a:avLst/>
+          </a:prstGeom>
+          <a:noFill/>
+          <a:ln/>
+        </p:spPr>
+        <p:txBody>
+          <a:bodyPr wrap="square" lIns="0" tIns="0" rIns="0" bIns="0" rtlCol="0" anchor="ctr"/>
+          <a:lstStyle/>
+          <a:p>
+            <a:pPr algn="ctr" indent="0" marL="0">
+              <a:buNone/>
+            </a:pPr>
+            <a:r>
+              <a:rPr lang="en-US" sz="2000" b="1" dirty="0">
+                <a:solidFill>
+                  <a:schemeClr val="bg1"/>
+                </a:solidFill>
+              </a:rPr>
+              <a:t>R</a:t>
+            </a:r>
+            <a:endParaRPr lang="en-US" sz="2000" dirty="0"/>
+          </a:p>
+        </p:txBody>
+      </p:sp>
+      <p:sp>
+        <p:nvSpPr>
+          <p:cNvPr id="19" name="Cuarto O"/>
+          <p:cNvSpPr/>
+          <p:nvPr/>
+        </p:nvSpPr>
+        <p:spPr>
+          <a:xfrm>
+            <a:off x="9875520" y="1005840"/>
+            <a:ext cx="1828800" cy="1828800"/>
+          </a:xfrm>
+          <a:prstGeom prst="blockArc">
+            <a:avLst>
+              <a:gd name="adj1" fmla="val 10800000"/>
+              <a:gd name="adj2" fmla="val 16200000"/>
+              <a:gd name="adj3" fmla="val 21000"/>
+            </a:avLst>
+          </a:prstGeom>
+          <a:solidFill>
+            <a:schemeClr val="accent6"/>
+          </a:solidFill>
+          <a:ln w="25400">
+            <a:solidFill>
+              <a:schemeClr val="bg1"/>
+            </a:solidFill>
+            <a:prstDash val="solid"/>
+          </a:ln>
+        </p:spPr>
+      </p:sp>
+      <p:sp>
+        <p:nvSpPr>
+          <p:cNvPr id="20" name="Letra anillo O"/>
+          <p:cNvSpPr txBox="1"/>
+          <p:nvPr/>
+        </p:nvSpPr>
+        <p:spPr>
+          <a:xfrm>
+            <a:off x="10077955" y="1208275"/>
+            <a:ext cx="402336" cy="402336"/>
+          </a:xfrm>
+          <a:prstGeom prst="rect">
+            <a:avLst/>
+          </a:prstGeom>
+          <a:noFill/>
+          <a:ln/>
+        </p:spPr>
+        <p:txBody>
+          <a:bodyPr wrap="square" lIns="0" tIns="0" rIns="0" bIns="0" rtlCol="0" anchor="ctr"/>
+          <a:lstStyle/>
+          <a:p>
+            <a:pPr algn="ctr" indent="0" marL="0">
+              <a:buNone/>
+            </a:pPr>
+            <a:r>
+              <a:rPr lang="en-US" sz="2000" b="1" dirty="0">
+                <a:solidFill>
+                  <a:schemeClr val="bg1"/>
+                </a:solidFill>
+              </a:rPr>
+              <a:t>O</a:t>
+            </a:r>
+            <a:endParaRPr lang="en-US" sz="2000" dirty="0"/>
+          </a:p>
+        </p:txBody>
+      </p:sp>
+      <p:sp>
+        <p:nvSpPr>
+          <p:cNvPr id="21" name="Centro PMO360"/>
+          <p:cNvSpPr txBox="1"/>
+          <p:nvPr/>
+        </p:nvSpPr>
+        <p:spPr>
+          <a:xfrm>
+            <a:off x="10332720" y="1463040"/>
+            <a:ext cx="914400" cy="914400"/>
+          </a:xfrm>
+          <a:prstGeom prst="rect">
+            <a:avLst/>
+          </a:prstGeom>
+          <a:noFill/>
+          <a:ln/>
+        </p:spPr>
+        <p:txBody>
+          <a:bodyPr wrap="square" lIns="0" tIns="0" rIns="0" bIns="0" rtlCol="0" anchor="ctr"/>
+          <a:lstStyle/>
+          <a:p>
+            <a:pPr algn="ctr" indent="0" marL="0">
+              <a:buNone/>
+            </a:pPr>
+            <a:r>
+              <a:rPr lang="en-US" sz="1800" b="1" dirty="0">
+                <a:solidFill>
+                  <a:schemeClr val="tx2"/>
+                </a:solidFill>
+              </a:rPr>
+              <a:t>PMO</a:t>
+            </a:r>
+            <a:endParaRPr lang="en-US" sz="1800" dirty="0"/>
+          </a:p>
+          <a:p>
+            <a:pPr algn="ctr" indent="0" marL="0">
+              <a:buNone/>
+            </a:pPr>
+            <a:r>
+              <a:rPr lang="en-US" sz="2400" b="1" dirty="0">
+                <a:solidFill>
+                  <a:schemeClr val="accent1"/>
+                </a:solidFill>
+              </a:rPr>
+              <a:t>360</a:t>
+            </a:r>
+            <a:endParaRPr lang="en-US" sz="1800" dirty="0"/>
+          </a:p>
+        </p:txBody>
+      </p:sp>
+      <p:sp>
+        <p:nvSpPr>
+          <p:cNvPr id="22" name="Tarjeta F"/>
           <p:cNvSpPr/>
           <p:nvPr/>
         </p:nvSpPr>
@@ -1222,7 +1544,7 @@
       </p:sp>
       <p:sp>
         <p:nvSpPr>
-          <p:cNvPr id="14" name="Círculo F"/>
+          <p:cNvPr id="23" name="Círculo F"/>
           <p:cNvSpPr/>
           <p:nvPr/>
         </p:nvSpPr>
@@ -1242,7 +1564,7 @@
       </p:sp>
       <p:sp>
         <p:nvSpPr>
-          <p:cNvPr id="15" name="Letra F"/>
+          <p:cNvPr id="24" name="Letra F"/>
           <p:cNvSpPr txBox="1"/>
           <p:nvPr/>
         </p:nvSpPr>
@@ -1278,7 +1600,7 @@
       </p:sp>
       <p:sp>
         <p:nvSpPr>
-          <p:cNvPr id="16" name="Paso F"/>
+          <p:cNvPr id="25" name="Paso F"/>
           <p:cNvSpPr txBox="1"/>
           <p:nvPr/>
         </p:nvSpPr>
@@ -1314,7 +1636,7 @@
       </p:sp>
       <p:sp>
         <p:nvSpPr>
-          <p:cNvPr id="17" name="Imagen F"/>
+          <p:cNvPr id="26" name="Imagen F"/>
           <p:cNvSpPr txBox="1"/>
           <p:nvPr/>
         </p:nvSpPr>
@@ -1350,7 +1672,7 @@
       </p:sp>
       <p:sp>
         <p:nvSpPr>
-          <p:cNvPr id="18" name="Problema F"/>
+          <p:cNvPr id="27" name="Problema F"/>
           <p:cNvSpPr txBox="1"/>
           <p:nvPr/>
         </p:nvSpPr>
@@ -1386,7 +1708,7 @@
       </p:sp>
       <p:sp>
         <p:nvSpPr>
-          <p:cNvPr id="19" name="Evidencia F"/>
+          <p:cNvPr id="28" name="Evidencia F"/>
           <p:cNvSpPr txBox="1"/>
           <p:nvPr/>
         </p:nvSpPr>
@@ -1444,7 +1766,7 @@
       </p:sp>
       <p:sp>
         <p:nvSpPr>
-          <p:cNvPr id="20" name="Tarjeta A"/>
+          <p:cNvPr id="29" name="Tarjeta A"/>
           <p:cNvSpPr/>
           <p:nvPr/>
         </p:nvSpPr>
@@ -1466,7 +1788,7 @@
       </p:sp>
       <p:sp>
         <p:nvSpPr>
-          <p:cNvPr id="21" name="Círculo A"/>
+          <p:cNvPr id="30" name="Círculo A"/>
           <p:cNvSpPr/>
           <p:nvPr/>
         </p:nvSpPr>
@@ -1486,7 +1808,7 @@
       </p:sp>
       <p:sp>
         <p:nvSpPr>
-          <p:cNvPr id="22" name="Letra A"/>
+          <p:cNvPr id="31" name="Letra A"/>
           <p:cNvSpPr txBox="1"/>
           <p:nvPr/>
         </p:nvSpPr>
@@ -1522,7 +1844,7 @@
       </p:sp>
       <p:sp>
         <p:nvSpPr>
-          <p:cNvPr id="23" name="Paso A"/>
+          <p:cNvPr id="32" name="Paso A"/>
           <p:cNvSpPr txBox="1"/>
           <p:nvPr/>
         </p:nvSpPr>
@@ -1558,7 +1880,7 @@
       </p:sp>
       <p:sp>
         <p:nvSpPr>
-          <p:cNvPr id="24" name="Imagen A"/>
+          <p:cNvPr id="33" name="Imagen A"/>
           <p:cNvSpPr txBox="1"/>
           <p:nvPr/>
         </p:nvSpPr>
@@ -1594,7 +1916,7 @@
       </p:sp>
       <p:sp>
         <p:nvSpPr>
-          <p:cNvPr id="25" name="Problema A"/>
+          <p:cNvPr id="34" name="Problema A"/>
           <p:cNvSpPr txBox="1"/>
           <p:nvPr/>
         </p:nvSpPr>
@@ -1630,7 +1952,7 @@
       </p:sp>
       <p:sp>
         <p:nvSpPr>
-          <p:cNvPr id="26" name="Evidencia A"/>
+          <p:cNvPr id="35" name="Evidencia A"/>
           <p:cNvSpPr txBox="1"/>
           <p:nvPr/>
         </p:nvSpPr>
@@ -1706,7 +2028,7 @@
       </p:sp>
       <p:sp>
         <p:nvSpPr>
-          <p:cNvPr id="27" name="Tarjeta R"/>
+          <p:cNvPr id="36" name="Tarjeta R"/>
           <p:cNvSpPr/>
           <p:nvPr/>
         </p:nvSpPr>
@@ -1728,7 +2050,7 @@
       </p:sp>
       <p:sp>
         <p:nvSpPr>
-          <p:cNvPr id="28" name="Círculo R"/>
+          <p:cNvPr id="37" name="Círculo R"/>
           <p:cNvSpPr/>
           <p:nvPr/>
         </p:nvSpPr>
@@ -1748,7 +2070,7 @@
       </p:sp>
       <p:sp>
         <p:nvSpPr>
-          <p:cNvPr id="29" name="Letra R"/>
+          <p:cNvPr id="38" name="Letra R"/>
           <p:cNvSpPr txBox="1"/>
           <p:nvPr/>
         </p:nvSpPr>
@@ -1784,7 +2106,7 @@
       </p:sp>
       <p:sp>
         <p:nvSpPr>
-          <p:cNvPr id="30" name="Paso R"/>
+          <p:cNvPr id="39" name="Paso R"/>
           <p:cNvSpPr txBox="1"/>
           <p:nvPr/>
         </p:nvSpPr>
@@ -1820,7 +2142,7 @@
       </p:sp>
       <p:sp>
         <p:nvSpPr>
-          <p:cNvPr id="31" name="Imagen R"/>
+          <p:cNvPr id="40" name="Imagen R"/>
           <p:cNvSpPr txBox="1"/>
           <p:nvPr/>
         </p:nvSpPr>
@@ -1856,7 +2178,7 @@
       </p:sp>
       <p:sp>
         <p:nvSpPr>
-          <p:cNvPr id="32" name="Problema R"/>
+          <p:cNvPr id="41" name="Problema R"/>
           <p:cNvSpPr txBox="1"/>
           <p:nvPr/>
         </p:nvSpPr>
@@ -1892,7 +2214,7 @@
       </p:sp>
       <p:sp>
         <p:nvSpPr>
-          <p:cNvPr id="33" name="Evidencia R"/>
+          <p:cNvPr id="42" name="Evidencia R"/>
           <p:cNvSpPr txBox="1"/>
           <p:nvPr/>
         </p:nvSpPr>
@@ -1968,7 +2290,7 @@
       </p:sp>
       <p:sp>
         <p:nvSpPr>
-          <p:cNvPr id="34" name="Tarjeta O"/>
+          <p:cNvPr id="43" name="Tarjeta O"/>
           <p:cNvSpPr/>
           <p:nvPr/>
         </p:nvSpPr>
@@ -1990,7 +2312,7 @@
       </p:sp>
       <p:sp>
         <p:nvSpPr>
-          <p:cNvPr id="35" name="Círculo O"/>
+          <p:cNvPr id="44" name="Círculo O"/>
           <p:cNvSpPr/>
           <p:nvPr/>
         </p:nvSpPr>
@@ -2010,7 +2332,7 @@
       </p:sp>
       <p:sp>
         <p:nvSpPr>
-          <p:cNvPr id="36" name="Letra O"/>
+          <p:cNvPr id="45" name="Letra O"/>
           <p:cNvSpPr txBox="1"/>
           <p:nvPr/>
         </p:nvSpPr>
@@ -2046,7 +2368,7 @@
       </p:sp>
       <p:sp>
         <p:nvSpPr>
-          <p:cNvPr id="37" name="Paso O"/>
+          <p:cNvPr id="46" name="Paso O"/>
           <p:cNvSpPr txBox="1"/>
           <p:nvPr/>
         </p:nvSpPr>
@@ -2082,7 +2404,7 @@
       </p:sp>
       <p:sp>
         <p:nvSpPr>
-          <p:cNvPr id="38" name="Imagen O"/>
+          <p:cNvPr id="47" name="Imagen O"/>
           <p:cNvSpPr txBox="1"/>
           <p:nvPr/>
         </p:nvSpPr>
@@ -2118,7 +2440,7 @@
       </p:sp>
       <p:sp>
         <p:nvSpPr>
-          <p:cNvPr id="39" name="Problema O"/>
+          <p:cNvPr id="48" name="Problema O"/>
           <p:cNvSpPr txBox="1"/>
           <p:nvPr/>
         </p:nvSpPr>
@@ -2154,7 +2476,7 @@
       </p:sp>
       <p:sp>
         <p:nvSpPr>
-          <p:cNvPr id="40" name="Evidencia O"/>
+          <p:cNvPr id="49" name="Evidencia O"/>
           <p:cNvSpPr txBox="1"/>
           <p:nvPr/>
         </p:nvSpPr>
@@ -2230,7 +2552,7 @@
       </p:sp>
       <p:sp>
         <p:nvSpPr>
-          <p:cNvPr id="41" name="Caja pedido"/>
+          <p:cNvPr id="50" name="Caja pedido"/>
           <p:cNvSpPr/>
           <p:nvPr/>
         </p:nvSpPr>
@@ -2252,7 +2574,7 @@
       </p:sp>
       <p:sp>
         <p:nvSpPr>
-          <p:cNvPr id="42" name="Texto pedido"/>
+          <p:cNvPr id="51" name="Texto pedido"/>
           <p:cNvSpPr txBox="1"/>
           <p:nvPr/>
         </p:nvSpPr>
@@ -2302,7 +2624,7 @@
       </p:sp>
       <p:sp>
         <p:nvSpPr>
-          <p:cNvPr id="43" name="Caja declaración"/>
+          <p:cNvPr id="52" name="Caja declaración"/>
           <p:cNvSpPr/>
           <p:nvPr/>
         </p:nvSpPr>
@@ -2329,7 +2651,7 @@
       </p:sp>
       <p:sp>
         <p:nvSpPr>
-          <p:cNvPr id="44" name="Texto declaración"/>
+          <p:cNvPr id="53" name="Texto declaración"/>
           <p:cNvSpPr txBox="1"/>
           <p:nvPr/>
         </p:nvSpPr>

</xml_diff>